<commit_message>
updated powerpoint and catalan.c
</commit_message>
<xml_diff>
--- a/catalan.pptx
+++ b/catalan.pptx
@@ -206,7 +206,7 @@
           <a:p>
             <a:fld id="{2CA80483-8405-594F-95F8-D3FBF1CBF066}" type="datetimeFigureOut">
               <a:rPr lang="en-US" smtClean="0"/>
-              <a:t>4/17/2026</a:t>
+              <a:t>4/18/2026</a:t>
             </a:fld>
             <a:endParaRPr lang="en-US"/>
           </a:p>
@@ -6725,7 +6725,7 @@
           <a:p>
             <a:fld id="{66E687FF-D228-AF49-87D5-A473DBACE8EB}" type="datetime1">
               <a:rPr lang="en-US" smtClean="0"/>
-              <a:t>4/17/2026</a:t>
+              <a:t>4/18/2026</a:t>
             </a:fld>
             <a:endParaRPr lang="en-US"/>
           </a:p>
@@ -7402,17 +7402,25 @@
           <a:p>
             <a:r>
               <a:rPr lang="en-US" dirty="0"/>
+              <a:t>Introducing parallelism does not result in better performance</a:t>
+            </a:r>
+          </a:p>
+          <a:p>
+            <a:pPr lvl="1"/>
+            <a:r>
+              <a:rPr lang="en-US" dirty="0"/>
               <a:t>Time complexity is worse than sequential because overhead dependencies</a:t>
             </a:r>
           </a:p>
           <a:p>
+            <a:pPr lvl="1"/>
             <a:r>
               <a:rPr lang="en-US" dirty="0"/>
               <a:t>Space complexity is worse than sequential because multithreaded still uses N manager threads and up to 4 worker threads</a:t>
             </a:r>
           </a:p>
           <a:p>
-            <a:pPr lvl="1"/>
+            <a:pPr lvl="2"/>
             <a:r>
               <a:rPr lang="en-US" dirty="0"/>
               <a:t>Pre-thread stack allocation is also higher</a:t>
@@ -7485,8 +7493,8 @@
           <a:chExt cx="0" cy="0"/>
         </a:xfrm>
       </p:grpSpPr>
-      <mc:AlternateContent xmlns:mc="http://schemas.openxmlformats.org/markup-compatibility/2006">
-        <mc:Choice xmlns:a14="http://schemas.microsoft.com/office/drawing/2010/main" Requires="a14">
+      <mc:AlternateContent xmlns:mc="http://schemas.openxmlformats.org/markup-compatibility/2006" xmlns:a14="http://schemas.microsoft.com/office/drawing/2010/main">
+        <mc:Choice Requires="a14">
           <p:sp>
             <p:nvSpPr>
               <p:cNvPr id="3" name="Content Placeholder 2">
@@ -7708,7 +7716,7 @@
             </p:txBody>
           </p:sp>
         </mc:Choice>
-        <mc:Fallback>
+        <mc:Fallback xmlns="">
           <p:sp>
             <p:nvSpPr>
               <p:cNvPr id="3" name="Content Placeholder 2">
@@ -7896,8 +7904,8 @@
           <a:chExt cx="0" cy="0"/>
         </a:xfrm>
       </p:grpSpPr>
-      <mc:AlternateContent xmlns:mc="http://schemas.openxmlformats.org/markup-compatibility/2006">
-        <mc:Choice xmlns:a14="http://schemas.microsoft.com/office/drawing/2010/main" Requires="a14">
+      <mc:AlternateContent xmlns:mc="http://schemas.openxmlformats.org/markup-compatibility/2006" xmlns:a14="http://schemas.microsoft.com/office/drawing/2010/main">
+        <mc:Choice Requires="a14">
           <p:sp>
             <p:nvSpPr>
               <p:cNvPr id="2" name="Content Placeholder 1">
@@ -8104,7 +8112,7 @@
             </p:txBody>
           </p:sp>
         </mc:Choice>
-        <mc:Fallback>
+        <mc:Fallback xmlns="">
           <p:sp>
             <p:nvSpPr>
               <p:cNvPr id="2" name="Content Placeholder 1">
@@ -8267,8 +8275,8 @@
           <a:chExt cx="0" cy="0"/>
         </a:xfrm>
       </p:grpSpPr>
-      <mc:AlternateContent xmlns:mc="http://schemas.openxmlformats.org/markup-compatibility/2006">
-        <mc:Choice xmlns:a14="http://schemas.microsoft.com/office/drawing/2010/main" Requires="a14">
+      <mc:AlternateContent xmlns:mc="http://schemas.openxmlformats.org/markup-compatibility/2006" xmlns:a14="http://schemas.microsoft.com/office/drawing/2010/main">
+        <mc:Choice Requires="a14">
           <p:sp>
             <p:nvSpPr>
               <p:cNvPr id="2" name="Content Placeholder 1">
@@ -8658,7 +8666,7 @@
             </p:txBody>
           </p:sp>
         </mc:Choice>
-        <mc:Fallback>
+        <mc:Fallback xmlns="">
           <p:sp>
             <p:nvSpPr>
               <p:cNvPr id="2" name="Content Placeholder 1">
@@ -9179,8 +9187,8 @@
           <a:chExt cx="0" cy="0"/>
         </a:xfrm>
       </p:grpSpPr>
-      <mc:AlternateContent xmlns:mc="http://schemas.openxmlformats.org/markup-compatibility/2006">
-        <mc:Choice xmlns:a14="http://schemas.microsoft.com/office/drawing/2010/main" Requires="a14">
+      <mc:AlternateContent xmlns:mc="http://schemas.openxmlformats.org/markup-compatibility/2006" xmlns:a14="http://schemas.microsoft.com/office/drawing/2010/main">
+        <mc:Choice Requires="a14">
           <p:sp>
             <p:nvSpPr>
               <p:cNvPr id="2" name="Content Placeholder 1">
@@ -9436,7 +9444,7 @@
             </p:txBody>
           </p:sp>
         </mc:Choice>
-        <mc:Fallback>
+        <mc:Fallback xmlns="">
           <p:sp>
             <p:nvSpPr>
               <p:cNvPr id="2" name="Content Placeholder 1">
@@ -9629,55 +9637,342 @@
           <a:chExt cx="0" cy="0"/>
         </a:xfrm>
       </p:grpSpPr>
+      <p:sp>
+        <p:nvSpPr>
+          <p:cNvPr id="6" name="Content Placeholder 5">
+            <a:extLst>
+              <a:ext uri="{FF2B5EF4-FFF2-40B4-BE49-F238E27FC236}">
+                <a16:creationId xmlns:a16="http://schemas.microsoft.com/office/drawing/2014/main" id="{F0405C86-1588-F943-FD88-08AD735CF119}"/>
+              </a:ext>
+            </a:extLst>
+          </p:cNvPr>
+          <p:cNvSpPr>
+            <a:spLocks noGrp="1"/>
+          </p:cNvSpPr>
+          <p:nvPr>
+            <p:ph sz="half" idx="1"/>
+          </p:nvPr>
+        </p:nvSpPr>
+        <p:spPr>
+          <a:xfrm>
+            <a:off x="402264" y="1390262"/>
+            <a:ext cx="5541336" cy="4760752"/>
+          </a:xfrm>
+        </p:spPr>
+        <p:txBody>
+          <a:bodyPr>
+            <a:normAutofit lnSpcReduction="10000"/>
+          </a:bodyPr>
+          <a:lstStyle/>
+          <a:p>
+            <a:pPr marL="0" indent="0">
+              <a:buNone/>
+            </a:pPr>
+            <a:r>
+              <a:rPr lang="en-US" b="1" dirty="0"/>
+              <a:t>Methodology:</a:t>
+            </a:r>
+          </a:p>
+          <a:p>
+            <a:pPr marL="0" indent="0">
+              <a:buNone/>
+            </a:pPr>
+            <a:r>
+              <a:rPr lang="en-US" dirty="0"/>
+              <a:t>1. Initialize C(0)</a:t>
+            </a:r>
+            <a:br>
+              <a:rPr lang="en-US" dirty="0"/>
+            </a:br>
+            <a:r>
+              <a:rPr lang="en-US" dirty="0"/>
+              <a:t>2. Assign one manager thread per Catalan number</a:t>
+            </a:r>
+            <a:br>
+              <a:rPr lang="en-US" dirty="0"/>
+            </a:br>
+            <a:r>
+              <a:rPr lang="en-US" dirty="0"/>
+              <a:t>3. Wait for dependencies to be satisfied</a:t>
+            </a:r>
+            <a:br>
+              <a:rPr lang="en-US" dirty="0"/>
+            </a:br>
+            <a:r>
+              <a:rPr lang="en-US" dirty="0"/>
+              <a:t>4. Split each recurrence into worker-thread chunks</a:t>
+            </a:r>
+            <a:br>
+              <a:rPr lang="en-US" dirty="0"/>
+            </a:br>
+            <a:r>
+              <a:rPr lang="en-US" dirty="0"/>
+              <a:t>5. Compute partial sums in parallel</a:t>
+            </a:r>
+            <a:br>
+              <a:rPr lang="en-US" dirty="0"/>
+            </a:br>
+            <a:r>
+              <a:rPr lang="en-US" dirty="0"/>
+              <a:t>6. Combine and store results</a:t>
+            </a:r>
+            <a:br>
+              <a:rPr lang="en-US" dirty="0"/>
+            </a:br>
+            <a:r>
+              <a:rPr lang="en-US" dirty="0"/>
+              <a:t>7. Notify manager threads</a:t>
+            </a:r>
+          </a:p>
+          <a:p>
+            <a:pPr marL="0" indent="0">
+              <a:buNone/>
+            </a:pPr>
+            <a:endParaRPr lang="en-US" dirty="0"/>
+          </a:p>
+        </p:txBody>
+      </p:sp>
+      <p:pic>
+        <p:nvPicPr>
+          <p:cNvPr id="3" name="Content Placeholder 2">
+            <a:extLst>
+              <a:ext uri="{FF2B5EF4-FFF2-40B4-BE49-F238E27FC236}">
+                <a16:creationId xmlns:a16="http://schemas.microsoft.com/office/drawing/2014/main" id="{8F163B48-7DAC-79C0-49C3-EA5648CAFDCE}"/>
+              </a:ext>
+            </a:extLst>
+          </p:cNvPr>
+          <p:cNvPicPr>
+            <a:picLocks noGrp="1" noChangeAspect="1"/>
+          </p:cNvPicPr>
+          <p:nvPr>
+            <p:ph sz="half" idx="2"/>
+          </p:nvPr>
+        </p:nvPicPr>
+        <p:blipFill>
+          <a:blip r:embed="rId2"/>
+          <a:stretch>
+            <a:fillRect/>
+          </a:stretch>
+        </p:blipFill>
+        <p:spPr>
+          <a:xfrm>
+            <a:off x="6040621" y="1971449"/>
+            <a:ext cx="5772150" cy="1984433"/>
+          </a:xfrm>
+          <a:prstGeom prst="rect">
+            <a:avLst/>
+          </a:prstGeom>
+        </p:spPr>
+      </p:pic>
+      <p:sp>
+        <p:nvSpPr>
+          <p:cNvPr id="4" name="Title 3">
+            <a:extLst>
+              <a:ext uri="{FF2B5EF4-FFF2-40B4-BE49-F238E27FC236}">
+                <a16:creationId xmlns:a16="http://schemas.microsoft.com/office/drawing/2014/main" id="{857DD158-8775-D326-E8A2-DEA92A9DAE5A}"/>
+              </a:ext>
+            </a:extLst>
+          </p:cNvPr>
+          <p:cNvSpPr>
+            <a:spLocks noGrp="1"/>
+          </p:cNvSpPr>
+          <p:nvPr>
+            <p:ph type="title"/>
+          </p:nvPr>
+        </p:nvSpPr>
+        <p:spPr>
+          <a:xfrm>
+            <a:off x="402264" y="365125"/>
+            <a:ext cx="6065113" cy="1325563"/>
+          </a:xfrm>
+        </p:spPr>
+        <p:txBody>
+          <a:bodyPr/>
+          <a:lstStyle/>
+          <a:p>
+            <a:r>
+              <a:rPr lang="en-US" dirty="0"/>
+              <a:t>Multithread solution</a:t>
+            </a:r>
+          </a:p>
+        </p:txBody>
+      </p:sp>
+      <p:sp>
+        <p:nvSpPr>
+          <p:cNvPr id="5" name="Footer Placeholder 4">
+            <a:extLst>
+              <a:ext uri="{FF2B5EF4-FFF2-40B4-BE49-F238E27FC236}">
+                <a16:creationId xmlns:a16="http://schemas.microsoft.com/office/drawing/2014/main" id="{681395FF-1A3E-6D1D-791C-517B4F2E72E5}"/>
+              </a:ext>
+            </a:extLst>
+          </p:cNvPr>
+          <p:cNvSpPr>
+            <a:spLocks noGrp="1"/>
+          </p:cNvSpPr>
+          <p:nvPr>
+            <p:ph type="ftr" sz="quarter" idx="11"/>
+          </p:nvPr>
+        </p:nvSpPr>
+        <p:spPr/>
+        <p:txBody>
+          <a:bodyPr/>
+          <a:lstStyle/>
+          <a:p>
+            <a:r>
+              <a:rPr lang="en-US"/>
+              <a:t>UNIVERSITY OF SOUTH FLORIDA</a:t>
+            </a:r>
+            <a:endParaRPr lang="en-US" dirty="0"/>
+          </a:p>
+        </p:txBody>
+      </p:sp>
       <mc:AlternateContent xmlns:mc="http://schemas.openxmlformats.org/markup-compatibility/2006">
         <mc:Choice xmlns:a14="http://schemas.microsoft.com/office/drawing/2010/main" Requires="a14">
           <p:sp>
             <p:nvSpPr>
-              <p:cNvPr id="6" name="Content Placeholder 5">
+              <p:cNvPr id="9" name="TextBox 8">
                 <a:extLst>
                   <a:ext uri="{FF2B5EF4-FFF2-40B4-BE49-F238E27FC236}">
-                    <a16:creationId xmlns:a16="http://schemas.microsoft.com/office/drawing/2014/main" id="{F0405C86-1588-F943-FD88-08AD735CF119}"/>
+                    <a16:creationId xmlns:a16="http://schemas.microsoft.com/office/drawing/2014/main" id="{0A4D7A0E-3DCD-B59C-8124-1E58D8DDD71B}"/>
                   </a:ext>
                 </a:extLst>
               </p:cNvPr>
-              <p:cNvSpPr>
-                <a:spLocks noGrp="1"/>
-              </p:cNvSpPr>
-              <p:nvPr>
-                <p:ph sz="half" idx="1"/>
-              </p:nvPr>
+              <p:cNvSpPr txBox="1"/>
+              <p:nvPr/>
             </p:nvSpPr>
-            <p:spPr/>
+            <p:spPr>
+              <a:xfrm>
+                <a:off x="6467377" y="4881000"/>
+                <a:ext cx="5541336" cy="890500"/>
+              </a:xfrm>
+              <a:prstGeom prst="rect">
+                <a:avLst/>
+              </a:prstGeom>
+            </p:spPr>
             <p:txBody>
-              <a:bodyPr>
+              <a:bodyPr vert="horz" lIns="91440" tIns="45720" rIns="91440" bIns="45720" rtlCol="0">
                 <a:normAutofit/>
               </a:bodyPr>
-              <a:lstStyle/>
+              <a:lstStyle>
+                <a:lvl1pPr indent="0">
+                  <a:lnSpc>
+                    <a:spcPct val="90000"/>
+                  </a:lnSpc>
+                  <a:spcBef>
+                    <a:spcPts val="1000"/>
+                  </a:spcBef>
+                  <a:buFont typeface="Arial" panose="020B0604020202020204" pitchFamily="34" charset="0"/>
+                  <a:buNone/>
+                  <a:defRPr sz="2800" b="1">
+                    <a:solidFill>
+                      <a:schemeClr val="tx2"/>
+                    </a:solidFill>
+                  </a:defRPr>
+                </a:lvl1pPr>
+                <a:lvl2pPr marL="685783" indent="-228594">
+                  <a:lnSpc>
+                    <a:spcPct val="90000"/>
+                  </a:lnSpc>
+                  <a:spcBef>
+                    <a:spcPts val="500"/>
+                  </a:spcBef>
+                  <a:buFont typeface="Arial" panose="020B0604020202020204" pitchFamily="34" charset="0"/>
+                  <a:buChar char="•"/>
+                  <a:defRPr sz="2400">
+                    <a:solidFill>
+                      <a:schemeClr val="tx2"/>
+                    </a:solidFill>
+                  </a:defRPr>
+                </a:lvl2pPr>
+                <a:lvl3pPr marL="1142971" indent="-228594">
+                  <a:lnSpc>
+                    <a:spcPct val="90000"/>
+                  </a:lnSpc>
+                  <a:spcBef>
+                    <a:spcPts val="500"/>
+                  </a:spcBef>
+                  <a:buFont typeface="Arial" panose="020B0604020202020204" pitchFamily="34" charset="0"/>
+                  <a:buChar char="•"/>
+                  <a:defRPr sz="2000">
+                    <a:solidFill>
+                      <a:schemeClr val="tx2"/>
+                    </a:solidFill>
+                  </a:defRPr>
+                </a:lvl3pPr>
+                <a:lvl4pPr marL="1600160" indent="-228594">
+                  <a:lnSpc>
+                    <a:spcPct val="90000"/>
+                  </a:lnSpc>
+                  <a:spcBef>
+                    <a:spcPts val="500"/>
+                  </a:spcBef>
+                  <a:buFont typeface="Arial" panose="020B0604020202020204" pitchFamily="34" charset="0"/>
+                  <a:buChar char="•"/>
+                  <a:defRPr>
+                    <a:solidFill>
+                      <a:schemeClr val="tx2"/>
+                    </a:solidFill>
+                  </a:defRPr>
+                </a:lvl4pPr>
+                <a:lvl5pPr marL="2057349" indent="-228594">
+                  <a:lnSpc>
+                    <a:spcPct val="90000"/>
+                  </a:lnSpc>
+                  <a:spcBef>
+                    <a:spcPts val="500"/>
+                  </a:spcBef>
+                  <a:buFont typeface="Arial" panose="020B0604020202020204" pitchFamily="34" charset="0"/>
+                  <a:buChar char="•"/>
+                  <a:defRPr>
+                    <a:solidFill>
+                      <a:schemeClr val="tx2"/>
+                    </a:solidFill>
+                  </a:defRPr>
+                </a:lvl5pPr>
+                <a:lvl6pPr marL="2514537" indent="-228594">
+                  <a:lnSpc>
+                    <a:spcPct val="90000"/>
+                  </a:lnSpc>
+                  <a:spcBef>
+                    <a:spcPts val="500"/>
+                  </a:spcBef>
+                  <a:buFont typeface="Arial" panose="020B0604020202020204" pitchFamily="34" charset="0"/>
+                  <a:buChar char="•"/>
+                </a:lvl6pPr>
+                <a:lvl7pPr marL="2971726" indent="-228594">
+                  <a:lnSpc>
+                    <a:spcPct val="90000"/>
+                  </a:lnSpc>
+                  <a:spcBef>
+                    <a:spcPts val="500"/>
+                  </a:spcBef>
+                  <a:buFont typeface="Arial" panose="020B0604020202020204" pitchFamily="34" charset="0"/>
+                  <a:buChar char="•"/>
+                </a:lvl7pPr>
+                <a:lvl8pPr marL="3428914" indent="-228594">
+                  <a:lnSpc>
+                    <a:spcPct val="90000"/>
+                  </a:lnSpc>
+                  <a:spcBef>
+                    <a:spcPts val="500"/>
+                  </a:spcBef>
+                  <a:buFont typeface="Arial" panose="020B0604020202020204" pitchFamily="34" charset="0"/>
+                  <a:buChar char="•"/>
+                </a:lvl8pPr>
+                <a:lvl9pPr marL="3886103" indent="-228594">
+                  <a:lnSpc>
+                    <a:spcPct val="90000"/>
+                  </a:lnSpc>
+                  <a:spcBef>
+                    <a:spcPts val="500"/>
+                  </a:spcBef>
+                  <a:buFont typeface="Arial" panose="020B0604020202020204" pitchFamily="34" charset="0"/>
+                  <a:buChar char="•"/>
+                </a:lvl9pPr>
+              </a:lstStyle>
               <a:p>
-                <a:pPr marL="0" indent="0">
-                  <a:buNone/>
-                </a:pPr>
-                <a:r>
-                  <a:rPr lang="en-US" b="1" dirty="0"/>
-                  <a:t>Goal: </a:t>
-                </a:r>
                 <a:r>
                   <a:rPr lang="en-US" dirty="0"/>
-                  <a:t>compute Catalan numbers C(0) to C(n) </a:t>
-                </a:r>
-              </a:p>
-              <a:p>
-                <a:pPr marL="0" indent="0">
-                  <a:buNone/>
-                </a:pPr>
-                <a:endParaRPr lang="en-US" b="1" dirty="0"/>
-              </a:p>
-              <a:p>
-                <a:pPr marL="0" indent="0">
-                  <a:buNone/>
-                </a:pPr>
-                <a:r>
-                  <a:rPr lang="en-US" b="1" dirty="0"/>
                   <a:t>Key formula: </a:t>
                 </a:r>
                 <a14:m>
@@ -9685,41 +9980,31 @@
                     <m:sSub>
                       <m:sSubPr>
                         <m:ctrlPr>
-                          <a:rPr lang="en-US" i="1">
-                            <a:latin typeface="Cambria Math" panose="02040503050406030204" pitchFamily="18" charset="0"/>
-                          </a:rPr>
+                          <a:rPr lang="en-US"/>
                         </m:ctrlPr>
                       </m:sSubPr>
                       <m:e>
                         <m:r>
-                          <a:rPr lang="en-US" i="1">
-                            <a:latin typeface="Cambria Math" panose="02040503050406030204" pitchFamily="18" charset="0"/>
-                          </a:rPr>
+                          <a:rPr lang="en-US"/>
                           <m:t>𝐶</m:t>
                         </m:r>
                       </m:e>
                       <m:sub>
                         <m:r>
-                          <a:rPr lang="en-US" i="1">
-                            <a:latin typeface="Cambria Math" panose="02040503050406030204" pitchFamily="18" charset="0"/>
-                          </a:rPr>
+                          <a:rPr lang="en-US"/>
                           <m:t>𝑛</m:t>
                         </m:r>
                       </m:sub>
                     </m:sSub>
                     <m:r>
-                      <a:rPr lang="en-US" i="1">
-                        <a:latin typeface="Cambria Math" panose="02040503050406030204" pitchFamily="18" charset="0"/>
-                      </a:rPr>
+                      <a:rPr lang="en-US"/>
                       <m:t>= </m:t>
                     </m:r>
                     <m:nary>
                       <m:naryPr>
                         <m:chr m:val="∑"/>
                         <m:ctrlPr>
-                          <a:rPr lang="en-US" i="1">
-                            <a:latin typeface="Cambria Math" panose="02040503050406030204" pitchFamily="18" charset="0"/>
-                          </a:rPr>
+                          <a:rPr lang="en-US"/>
                         </m:ctrlPr>
                       </m:naryPr>
                       <m:sub>
@@ -9727,29 +10012,21 @@
                           <m:rPr>
                             <m:brk m:alnAt="23"/>
                           </m:rPr>
-                          <a:rPr lang="en-US" i="1">
-                            <a:latin typeface="Cambria Math" panose="02040503050406030204" pitchFamily="18" charset="0"/>
-                          </a:rPr>
+                          <a:rPr lang="en-US"/>
                           <m:t>𝑖</m:t>
                         </m:r>
                         <m:r>
-                          <a:rPr lang="en-US" i="1">
-                            <a:latin typeface="Cambria Math" panose="02040503050406030204" pitchFamily="18" charset="0"/>
-                          </a:rPr>
+                          <a:rPr lang="en-US"/>
                           <m:t>=0</m:t>
                         </m:r>
                       </m:sub>
                       <m:sup>
                         <m:r>
-                          <a:rPr lang="en-US" i="1">
-                            <a:latin typeface="Cambria Math" panose="02040503050406030204" pitchFamily="18" charset="0"/>
-                          </a:rPr>
+                          <a:rPr lang="en-US"/>
                           <m:t>𝑛</m:t>
                         </m:r>
                         <m:r>
-                          <a:rPr lang="en-US" i="1">
-                            <a:latin typeface="Cambria Math" panose="02040503050406030204" pitchFamily="18" charset="0"/>
-                          </a:rPr>
+                          <a:rPr lang="en-US"/>
                           <m:t>−1</m:t>
                         </m:r>
                       </m:sup>
@@ -9757,24 +10034,18 @@
                         <m:sSub>
                           <m:sSubPr>
                             <m:ctrlPr>
-                              <a:rPr lang="en-US" i="1">
-                                <a:latin typeface="Cambria Math" panose="02040503050406030204" pitchFamily="18" charset="0"/>
-                              </a:rPr>
+                              <a:rPr lang="en-US"/>
                             </m:ctrlPr>
                           </m:sSubPr>
                           <m:e>
                             <m:r>
-                              <a:rPr lang="en-US" i="1">
-                                <a:latin typeface="Cambria Math" panose="02040503050406030204" pitchFamily="18" charset="0"/>
-                              </a:rPr>
+                              <a:rPr lang="en-US"/>
                               <m:t>𝐶</m:t>
                             </m:r>
                           </m:e>
                           <m:sub>
                             <m:r>
-                              <a:rPr lang="en-US" i="1">
-                                <a:latin typeface="Cambria Math" panose="02040503050406030204" pitchFamily="18" charset="0"/>
-                              </a:rPr>
+                              <a:rPr lang="en-US"/>
                               <m:t>𝑖</m:t>
                             </m:r>
                           </m:sub>
@@ -9782,36 +10053,26 @@
                         <m:sSub>
                           <m:sSubPr>
                             <m:ctrlPr>
-                              <a:rPr lang="en-US" i="1">
-                                <a:latin typeface="Cambria Math" panose="02040503050406030204" pitchFamily="18" charset="0"/>
-                              </a:rPr>
+                              <a:rPr lang="en-US"/>
                             </m:ctrlPr>
                           </m:sSubPr>
                           <m:e>
                             <m:r>
-                              <a:rPr lang="en-US" i="1">
-                                <a:latin typeface="Cambria Math" panose="02040503050406030204" pitchFamily="18" charset="0"/>
-                              </a:rPr>
+                              <a:rPr lang="en-US"/>
                               <m:t>𝐶</m:t>
                             </m:r>
                           </m:e>
                           <m:sub>
                             <m:r>
-                              <a:rPr lang="en-US" i="1">
-                                <a:latin typeface="Cambria Math" panose="02040503050406030204" pitchFamily="18" charset="0"/>
-                              </a:rPr>
+                              <a:rPr lang="en-US"/>
                               <m:t>𝑛</m:t>
                             </m:r>
                             <m:r>
-                              <a:rPr lang="en-US" i="1">
-                                <a:latin typeface="Cambria Math" panose="02040503050406030204" pitchFamily="18" charset="0"/>
-                              </a:rPr>
+                              <a:rPr lang="en-US"/>
                               <m:t>−1−</m:t>
                             </m:r>
                             <m:r>
-                              <a:rPr lang="en-US" i="1">
-                                <a:latin typeface="Cambria Math" panose="02040503050406030204" pitchFamily="18" charset="0"/>
-                              </a:rPr>
+                              <a:rPr lang="en-US"/>
                               <m:t>𝑖</m:t>
                             </m:r>
                           </m:sub>
@@ -9822,37 +10083,36 @@
                 </a14:m>
                 <a:endParaRPr lang="en-US" dirty="0"/>
               </a:p>
-              <a:p>
-                <a:pPr marL="0" indent="0">
-                  <a:buNone/>
-                </a:pPr>
-                <a:endParaRPr lang="en-US" dirty="0"/>
-              </a:p>
             </p:txBody>
           </p:sp>
         </mc:Choice>
         <mc:Fallback>
           <p:sp>
             <p:nvSpPr>
-              <p:cNvPr id="6" name="Content Placeholder 5">
+              <p:cNvPr id="9" name="TextBox 8">
                 <a:extLst>
                   <a:ext uri="{FF2B5EF4-FFF2-40B4-BE49-F238E27FC236}">
-                    <a16:creationId xmlns:a16="http://schemas.microsoft.com/office/drawing/2014/main" id="{F0405C86-1588-F943-FD88-08AD735CF119}"/>
+                    <a16:creationId xmlns:a16="http://schemas.microsoft.com/office/drawing/2014/main" id="{0A4D7A0E-3DCD-B59C-8124-1E58D8DDD71B}"/>
                   </a:ext>
                 </a:extLst>
               </p:cNvPr>
-              <p:cNvSpPr>
-                <a:spLocks noGrp="1" noRot="1" noChangeAspect="1" noMove="1" noResize="1" noEditPoints="1" noAdjustHandles="1" noChangeArrowheads="1" noChangeShapeType="1" noTextEdit="1"/>
+              <p:cNvSpPr txBox="1">
+                <a:spLocks noRot="1" noChangeAspect="1" noMove="1" noResize="1" noEditPoints="1" noAdjustHandles="1" noChangeArrowheads="1" noChangeShapeType="1" noTextEdit="1"/>
               </p:cNvSpPr>
-              <p:nvPr>
-                <p:ph sz="half" idx="1"/>
-              </p:nvPr>
+              <p:nvPr/>
             </p:nvSpPr>
             <p:spPr>
+              <a:xfrm>
+                <a:off x="6467377" y="4881000"/>
+                <a:ext cx="5541336" cy="890500"/>
+              </a:xfrm>
+              <a:prstGeom prst="rect">
+                <a:avLst/>
+              </a:prstGeom>
               <a:blipFill>
-                <a:blip r:embed="rId2"/>
+                <a:blip r:embed="rId3"/>
                 <a:stretch>
-                  <a:fillRect l="-2310" t="-2381" r="-880"/>
+                  <a:fillRect l="-2310" t="-10274"/>
                 </a:stretch>
               </a:blipFill>
             </p:spPr>
@@ -9873,157 +10133,158 @@
       </mc:AlternateContent>
       <p:sp>
         <p:nvSpPr>
-          <p:cNvPr id="7" name="Content Placeholder 6">
-            <a:extLst>
-              <a:ext uri="{FF2B5EF4-FFF2-40B4-BE49-F238E27FC236}">
-                <a16:creationId xmlns:a16="http://schemas.microsoft.com/office/drawing/2014/main" id="{63CB4BBB-66D2-68B2-20ED-09EF6612A0F6}"/>
-              </a:ext>
-            </a:extLst>
-          </p:cNvPr>
-          <p:cNvSpPr>
-            <a:spLocks noGrp="1"/>
-          </p:cNvSpPr>
-          <p:nvPr>
-            <p:ph sz="half" idx="2"/>
-          </p:nvPr>
-        </p:nvSpPr>
-        <p:spPr>
-          <a:xfrm>
-            <a:off x="6292700" y="1815735"/>
-            <a:ext cx="5771781" cy="4351339"/>
-          </a:xfrm>
-        </p:spPr>
-        <p:txBody>
-          <a:bodyPr>
-            <a:normAutofit fontScale="92500" lnSpcReduction="10000"/>
+          <p:cNvPr id="11" name="TextBox 10">
+            <a:extLst>
+              <a:ext uri="{FF2B5EF4-FFF2-40B4-BE49-F238E27FC236}">
+                <a16:creationId xmlns:a16="http://schemas.microsoft.com/office/drawing/2014/main" id="{0CED00D9-0798-BEC8-59CB-30CC098F6057}"/>
+              </a:ext>
+            </a:extLst>
+          </p:cNvPr>
+          <p:cNvSpPr txBox="1"/>
+          <p:nvPr/>
+        </p:nvSpPr>
+        <p:spPr>
+          <a:xfrm>
+            <a:off x="6189268" y="810704"/>
+            <a:ext cx="6097554" cy="867930"/>
+          </a:xfrm>
+          <a:prstGeom prst="rect">
+            <a:avLst/>
+          </a:prstGeom>
+        </p:spPr>
+        <p:txBody>
+          <a:bodyPr vert="horz" lIns="91440" tIns="45720" rIns="91440" bIns="45720" rtlCol="0">
+            <a:normAutofit/>
           </a:bodyPr>
-          <a:lstStyle/>
-          <a:p>
-            <a:pPr marL="0" indent="0">
+          <a:lstStyle>
+            <a:defPPr>
+              <a:defRPr lang="en-US"/>
+            </a:defPPr>
+            <a:lvl1pPr indent="0">
+              <a:lnSpc>
+                <a:spcPct val="90000"/>
+              </a:lnSpc>
+              <a:spcBef>
+                <a:spcPts val="1000"/>
+              </a:spcBef>
+              <a:buFont typeface="Arial" panose="020B0604020202020204" pitchFamily="34" charset="0"/>
               <a:buNone/>
-            </a:pPr>
-            <a:r>
-              <a:rPr lang="en-US" b="1" dirty="0"/>
-              <a:t>Methodology:</a:t>
-            </a:r>
-          </a:p>
-          <a:p>
-            <a:pPr marL="0" indent="0">
-              <a:buNone/>
-            </a:pPr>
-            <a:r>
-              <a:rPr lang="en-US" dirty="0"/>
-              <a:t>1. Initialize C(0)</a:t>
-            </a:r>
-            <a:br>
-              <a:rPr lang="en-US" dirty="0"/>
-            </a:br>
-            <a:r>
-              <a:rPr lang="en-US" dirty="0"/>
-              <a:t>2. Assign one manager thread per Catalan number</a:t>
-            </a:r>
-            <a:br>
-              <a:rPr lang="en-US" dirty="0"/>
-            </a:br>
-            <a:r>
-              <a:rPr lang="en-US" dirty="0"/>
-              <a:t>3. Wait for dependencies to be satisfied</a:t>
-            </a:r>
-            <a:br>
-              <a:rPr lang="en-US" dirty="0"/>
-            </a:br>
-            <a:r>
-              <a:rPr lang="en-US" dirty="0"/>
-              <a:t>4. Split each recurrence into worker-thread chunks</a:t>
-            </a:r>
-            <a:br>
-              <a:rPr lang="en-US" dirty="0"/>
-            </a:br>
-            <a:r>
-              <a:rPr lang="en-US" dirty="0"/>
-              <a:t>5. Compute partial sums in parallel</a:t>
-            </a:r>
-            <a:br>
-              <a:rPr lang="en-US" dirty="0"/>
-            </a:br>
-            <a:r>
-              <a:rPr lang="en-US" dirty="0"/>
-              <a:t>6. Combine and store results</a:t>
-            </a:r>
-            <a:br>
-              <a:rPr lang="en-US" dirty="0"/>
-            </a:br>
-            <a:r>
-              <a:rPr lang="en-US" dirty="0"/>
-              <a:t>7. Notify dependent threads</a:t>
-            </a:r>
-            <a:br>
-              <a:rPr lang="en-US" dirty="0"/>
-            </a:br>
-            <a:r>
-              <a:rPr lang="en-US" dirty="0"/>
-              <a:t>8. Verify against baseline</a:t>
-            </a:r>
-          </a:p>
-          <a:p>
-            <a:endParaRPr lang="en-US" dirty="0"/>
-          </a:p>
-        </p:txBody>
-      </p:sp>
-      <p:sp>
-        <p:nvSpPr>
-          <p:cNvPr id="4" name="Title 3">
-            <a:extLst>
-              <a:ext uri="{FF2B5EF4-FFF2-40B4-BE49-F238E27FC236}">
-                <a16:creationId xmlns:a16="http://schemas.microsoft.com/office/drawing/2014/main" id="{857DD158-8775-D326-E8A2-DEA92A9DAE5A}"/>
-              </a:ext>
-            </a:extLst>
-          </p:cNvPr>
-          <p:cNvSpPr>
-            <a:spLocks noGrp="1"/>
-          </p:cNvSpPr>
-          <p:nvPr>
-            <p:ph type="title"/>
-          </p:nvPr>
-        </p:nvSpPr>
-        <p:spPr/>
-        <p:txBody>
-          <a:bodyPr/>
-          <a:lstStyle/>
-          <a:p>
-            <a:r>
-              <a:rPr lang="en-US" dirty="0"/>
-              <a:t>Multithread solution</a:t>
-            </a:r>
-          </a:p>
-        </p:txBody>
-      </p:sp>
-      <p:sp>
-        <p:nvSpPr>
-          <p:cNvPr id="5" name="Footer Placeholder 4">
-            <a:extLst>
-              <a:ext uri="{FF2B5EF4-FFF2-40B4-BE49-F238E27FC236}">
-                <a16:creationId xmlns:a16="http://schemas.microsoft.com/office/drawing/2014/main" id="{681395FF-1A3E-6D1D-791C-517B4F2E72E5}"/>
-              </a:ext>
-            </a:extLst>
-          </p:cNvPr>
-          <p:cNvSpPr>
-            <a:spLocks noGrp="1"/>
-          </p:cNvSpPr>
-          <p:nvPr>
-            <p:ph type="ftr" sz="quarter" idx="11"/>
-          </p:nvPr>
-        </p:nvSpPr>
-        <p:spPr/>
-        <p:txBody>
-          <a:bodyPr/>
-          <a:lstStyle/>
-          <a:p>
-            <a:r>
-              <a:rPr lang="en-US"/>
-              <a:t>UNIVERSITY OF SOUTH FLORIDA</a:t>
-            </a:r>
-            <a:endParaRPr lang="en-US" dirty="0"/>
+              <a:defRPr sz="2800" b="1">
+                <a:solidFill>
+                  <a:schemeClr val="tx2"/>
+                </a:solidFill>
+              </a:defRPr>
+            </a:lvl1pPr>
+            <a:lvl2pPr marL="685783" indent="-228594">
+              <a:lnSpc>
+                <a:spcPct val="90000"/>
+              </a:lnSpc>
+              <a:spcBef>
+                <a:spcPts val="500"/>
+              </a:spcBef>
+              <a:buFont typeface="Arial" panose="020B0604020202020204" pitchFamily="34" charset="0"/>
+              <a:buChar char="•"/>
+              <a:defRPr sz="2400">
+                <a:solidFill>
+                  <a:schemeClr val="tx2"/>
+                </a:solidFill>
+              </a:defRPr>
+            </a:lvl2pPr>
+            <a:lvl3pPr marL="1142971" indent="-228594">
+              <a:lnSpc>
+                <a:spcPct val="90000"/>
+              </a:lnSpc>
+              <a:spcBef>
+                <a:spcPts val="500"/>
+              </a:spcBef>
+              <a:buFont typeface="Arial" panose="020B0604020202020204" pitchFamily="34" charset="0"/>
+              <a:buChar char="•"/>
+              <a:defRPr sz="2000">
+                <a:solidFill>
+                  <a:schemeClr val="tx2"/>
+                </a:solidFill>
+              </a:defRPr>
+            </a:lvl3pPr>
+            <a:lvl4pPr marL="1600160" indent="-228594">
+              <a:lnSpc>
+                <a:spcPct val="90000"/>
+              </a:lnSpc>
+              <a:spcBef>
+                <a:spcPts val="500"/>
+              </a:spcBef>
+              <a:buFont typeface="Arial" panose="020B0604020202020204" pitchFamily="34" charset="0"/>
+              <a:buChar char="•"/>
+              <a:defRPr>
+                <a:solidFill>
+                  <a:schemeClr val="tx2"/>
+                </a:solidFill>
+              </a:defRPr>
+            </a:lvl4pPr>
+            <a:lvl5pPr marL="2057349" indent="-228594">
+              <a:lnSpc>
+                <a:spcPct val="90000"/>
+              </a:lnSpc>
+              <a:spcBef>
+                <a:spcPts val="500"/>
+              </a:spcBef>
+              <a:buFont typeface="Arial" panose="020B0604020202020204" pitchFamily="34" charset="0"/>
+              <a:buChar char="•"/>
+              <a:defRPr>
+                <a:solidFill>
+                  <a:schemeClr val="tx2"/>
+                </a:solidFill>
+              </a:defRPr>
+            </a:lvl5pPr>
+            <a:lvl6pPr marL="2514537" indent="-228594">
+              <a:lnSpc>
+                <a:spcPct val="90000"/>
+              </a:lnSpc>
+              <a:spcBef>
+                <a:spcPts val="500"/>
+              </a:spcBef>
+              <a:buFont typeface="Arial" panose="020B0604020202020204" pitchFamily="34" charset="0"/>
+              <a:buChar char="•"/>
+            </a:lvl6pPr>
+            <a:lvl7pPr marL="2971726" indent="-228594">
+              <a:lnSpc>
+                <a:spcPct val="90000"/>
+              </a:lnSpc>
+              <a:spcBef>
+                <a:spcPts val="500"/>
+              </a:spcBef>
+              <a:buFont typeface="Arial" panose="020B0604020202020204" pitchFamily="34" charset="0"/>
+              <a:buChar char="•"/>
+            </a:lvl7pPr>
+            <a:lvl8pPr marL="3428914" indent="-228594">
+              <a:lnSpc>
+                <a:spcPct val="90000"/>
+              </a:lnSpc>
+              <a:spcBef>
+                <a:spcPts val="500"/>
+              </a:spcBef>
+              <a:buFont typeface="Arial" panose="020B0604020202020204" pitchFamily="34" charset="0"/>
+              <a:buChar char="•"/>
+            </a:lvl8pPr>
+            <a:lvl9pPr marL="3886103" indent="-228594">
+              <a:lnSpc>
+                <a:spcPct val="90000"/>
+              </a:lnSpc>
+              <a:spcBef>
+                <a:spcPts val="500"/>
+              </a:spcBef>
+              <a:buFont typeface="Arial" panose="020B0604020202020204" pitchFamily="34" charset="0"/>
+              <a:buChar char="•"/>
+            </a:lvl9pPr>
+          </a:lstStyle>
+          <a:p>
+            <a:r>
+              <a:rPr lang="en-US" dirty="0"/>
+              <a:t>Goal: </a:t>
+            </a:r>
+            <a:r>
+              <a:rPr lang="en-US" b="0" dirty="0"/>
+              <a:t>compute Catalan numbers C(0) to C(n) </a:t>
+            </a:r>
           </a:p>
         </p:txBody>
       </p:sp>
@@ -10948,18 +11209,130 @@
           <a:prstGeom prst="rect">
             <a:avLst/>
           </a:prstGeom>
-          <a:noFill/>
-        </p:spPr>
-        <p:txBody>
-          <a:bodyPr wrap="square" rtlCol="0">
-            <a:spAutoFit/>
+        </p:spPr>
+        <p:txBody>
+          <a:bodyPr vert="horz" lIns="91440" tIns="45720" rIns="91440" bIns="45720" rtlCol="0">
+            <a:normAutofit/>
           </a:bodyPr>
-          <a:lstStyle/>
-          <a:p>
-            <a:pPr marL="285750" indent="-285750">
+          <a:lstStyle>
+            <a:lvl1pPr marL="228594" indent="-228594">
+              <a:lnSpc>
+                <a:spcPct val="90000"/>
+              </a:lnSpc>
+              <a:spcBef>
+                <a:spcPts val="1000"/>
+              </a:spcBef>
               <a:buFont typeface="Arial" panose="020B0604020202020204" pitchFamily="34" charset="0"/>
               <a:buChar char="•"/>
-            </a:pPr>
+              <a:defRPr sz="2800">
+                <a:solidFill>
+                  <a:schemeClr val="tx2"/>
+                </a:solidFill>
+              </a:defRPr>
+            </a:lvl1pPr>
+            <a:lvl2pPr marL="685783" lvl="1" indent="-228594">
+              <a:lnSpc>
+                <a:spcPct val="90000"/>
+              </a:lnSpc>
+              <a:spcBef>
+                <a:spcPts val="500"/>
+              </a:spcBef>
+              <a:buFont typeface="Arial" panose="020B0604020202020204" pitchFamily="34" charset="0"/>
+              <a:buChar char="•"/>
+              <a:defRPr sz="2400">
+                <a:solidFill>
+                  <a:schemeClr val="tx2"/>
+                </a:solidFill>
+              </a:defRPr>
+            </a:lvl2pPr>
+            <a:lvl3pPr marL="1142971" lvl="2" indent="-228594">
+              <a:lnSpc>
+                <a:spcPct val="90000"/>
+              </a:lnSpc>
+              <a:spcBef>
+                <a:spcPts val="500"/>
+              </a:spcBef>
+              <a:buFont typeface="Arial" panose="020B0604020202020204" pitchFamily="34" charset="0"/>
+              <a:buChar char="•"/>
+              <a:defRPr sz="2000" i="1">
+                <a:solidFill>
+                  <a:schemeClr val="tx2"/>
+                </a:solidFill>
+                <a:latin typeface="Cambria Math" panose="02040503050406030204" pitchFamily="18" charset="0"/>
+              </a:defRPr>
+            </a:lvl3pPr>
+            <a:lvl4pPr marL="1600160" indent="-228594">
+              <a:lnSpc>
+                <a:spcPct val="90000"/>
+              </a:lnSpc>
+              <a:spcBef>
+                <a:spcPts val="500"/>
+              </a:spcBef>
+              <a:buFont typeface="Arial" panose="020B0604020202020204" pitchFamily="34" charset="0"/>
+              <a:buChar char="•"/>
+              <a:defRPr>
+                <a:solidFill>
+                  <a:schemeClr val="tx2"/>
+                </a:solidFill>
+              </a:defRPr>
+            </a:lvl4pPr>
+            <a:lvl5pPr marL="2057349" indent="-228594">
+              <a:lnSpc>
+                <a:spcPct val="90000"/>
+              </a:lnSpc>
+              <a:spcBef>
+                <a:spcPts val="500"/>
+              </a:spcBef>
+              <a:buFont typeface="Arial" panose="020B0604020202020204" pitchFamily="34" charset="0"/>
+              <a:buChar char="•"/>
+              <a:defRPr>
+                <a:solidFill>
+                  <a:schemeClr val="tx2"/>
+                </a:solidFill>
+              </a:defRPr>
+            </a:lvl5pPr>
+            <a:lvl6pPr marL="2514537" indent="-228594">
+              <a:lnSpc>
+                <a:spcPct val="90000"/>
+              </a:lnSpc>
+              <a:spcBef>
+                <a:spcPts val="500"/>
+              </a:spcBef>
+              <a:buFont typeface="Arial" panose="020B0604020202020204" pitchFamily="34" charset="0"/>
+              <a:buChar char="•"/>
+            </a:lvl6pPr>
+            <a:lvl7pPr marL="2971726" indent="-228594">
+              <a:lnSpc>
+                <a:spcPct val="90000"/>
+              </a:lnSpc>
+              <a:spcBef>
+                <a:spcPts val="500"/>
+              </a:spcBef>
+              <a:buFont typeface="Arial" panose="020B0604020202020204" pitchFamily="34" charset="0"/>
+              <a:buChar char="•"/>
+            </a:lvl7pPr>
+            <a:lvl8pPr marL="3428914" indent="-228594">
+              <a:lnSpc>
+                <a:spcPct val="90000"/>
+              </a:lnSpc>
+              <a:spcBef>
+                <a:spcPts val="500"/>
+              </a:spcBef>
+              <a:buFont typeface="Arial" panose="020B0604020202020204" pitchFamily="34" charset="0"/>
+              <a:buChar char="•"/>
+            </a:lvl8pPr>
+            <a:lvl9pPr marL="3886103" indent="-228594">
+              <a:lnSpc>
+                <a:spcPct val="90000"/>
+              </a:lnSpc>
+              <a:spcBef>
+                <a:spcPts val="500"/>
+              </a:spcBef>
+              <a:buFont typeface="Arial" panose="020B0604020202020204" pitchFamily="34" charset="0"/>
+              <a:buChar char="•"/>
+            </a:lvl9pPr>
+          </a:lstStyle>
+          <a:p>
             <a:r>
               <a:rPr lang="en-US" dirty="0"/>
               <a:t>Each manager waits until all dependencies are satisfied before executing their own Catalan number</a:t>
@@ -10997,8 +11370,8 @@
           <a:chExt cx="0" cy="0"/>
         </a:xfrm>
       </p:grpSpPr>
-      <mc:AlternateContent xmlns:mc="http://schemas.openxmlformats.org/markup-compatibility/2006">
-        <mc:Choice xmlns:a14="http://schemas.microsoft.com/office/drawing/2010/main" Requires="a14">
+      <mc:AlternateContent xmlns:mc="http://schemas.openxmlformats.org/markup-compatibility/2006" xmlns:a14="http://schemas.microsoft.com/office/drawing/2010/main">
+        <mc:Choice Requires="a14">
           <p:sp>
             <p:nvSpPr>
               <p:cNvPr id="5" name="Content Placeholder 4">
@@ -11263,7 +11636,7 @@
             </p:txBody>
           </p:sp>
         </mc:Choice>
-        <mc:Fallback>
+        <mc:Fallback xmlns="">
           <p:sp>
             <p:nvSpPr>
               <p:cNvPr id="5" name="Content Placeholder 4">

</xml_diff>